<commit_message>
Utilisation: take Rhys and Rodney out of the base — on leave
Both were on leave in the 28 Sep - 4 Oct week, so they were never available
capacity. Removed from the denominator and from the employee table:

  staff        9 -> 7        available  342h -> 266h
  billed   88.87h (unchanged - both logged nothing)
  utilisation  26.0% -> 33.4%
  ex the 50.5h record  11.2% -> 14.4%

The week-on-week panel keeps the earlier weeks on their 9-person base and
its note now states the base per week, so the series stays readable rather
than silently mixing denominators. The available-hours card names who was on
leave.

Co-Authored-By: Claude Opus 5 <noreply@anthropic.com>
Claude-Session: https://claude.ai/code/session_019YTPNjRj34XzLPLC9gKxc4
</commit_message>
<xml_diff>
--- a/exec-deck/output/H&L Weekly Update - WC 28 Sep 2026.pptx
+++ b/exec-deck/output/H&L Weekly Update - WC 28 Sep 2026.pptx
@@ -25408,7 +25408,7 @@
                 <a:ea typeface="Poppins" pitchFamily="34" charset="-122"/>
                 <a:cs typeface="Poppins" pitchFamily="34" charset="-120"/>
               </a:rPr>
-              <a:t>billable utilisation 26.0% — 88.9h of 342h, but one 50.5h record carries most of it; 11.2% without it</a:t>
+              <a:t>billable utilisation 33.4% — 88.9h of 266h with Rhys and Rodney on leave, but one 50.5h record carries most of it; 14.4% without it</a:t>
             </a:r>
             <a:endParaRPr lang="en-US" sz="900" dirty="0"/>
           </a:p>
@@ -39300,7 +39300,7 @@
                 <a:ea typeface="Poppins" pitchFamily="34" charset="-122"/>
                 <a:cs typeface="Poppins" pitchFamily="34" charset="-120"/>
               </a:rPr>
-              <a:t>26%</a:t>
+              <a:t>33.4%</a:t>
             </a:r>
             <a:endParaRPr lang="en-US" sz="2600" dirty="0"/>
           </a:p>
@@ -39339,7 +39339,7 @@
                 <a:ea typeface="Poppins" pitchFamily="34" charset="-122"/>
                 <a:cs typeface="Poppins" pitchFamily="34" charset="-120"/>
               </a:rPr>
-              <a:t>88.87h billed of 342h available · target 80% · one 50.5h record carries most of it</a:t>
+              <a:t>88.87h billed of 266h available · target 80% · one 50.5h record carries most of it</a:t>
             </a:r>
             <a:endParaRPr lang="en-US" sz="780" dirty="0"/>
           </a:p>
@@ -39446,7 +39446,7 @@
                 <a:ea typeface="Poppins" pitchFamily="34" charset="-122"/>
                 <a:cs typeface="Poppins" pitchFamily="34" charset="-120"/>
               </a:rPr>
-              <a:t>342h</a:t>
+              <a:t>266h</a:t>
             </a:r>
             <a:endParaRPr lang="en-US" sz="2600" dirty="0"/>
           </a:p>
@@ -39485,7 +39485,7 @@
                 <a:ea typeface="Poppins" pitchFamily="34" charset="-122"/>
                 <a:cs typeface="Poppins" pitchFamily="34" charset="-120"/>
               </a:rPr>
-              <a:t>9 people assigned to PS-pipeline tickets × 38h standard week</a:t>
+              <a:t>7 available × 38h · Rhys Woolcock and Rodney Nolan on leave</a:t>
             </a:r>
             <a:endParaRPr lang="en-US" sz="780" dirty="0"/>
           </a:p>
@@ -39923,7 +39923,7 @@
         <p:spPr>
           <a:xfrm>
             <a:off x="2944368" y="3017520"/>
-            <a:ext cx="5486" cy="1744675"/>
+            <a:ext cx="5486" cy="1664208"/>
           </a:xfrm>
           <a:prstGeom prst="rect">
             <a:avLst/>
@@ -39982,7 +39982,7 @@
         <p:spPr>
           <a:xfrm>
             <a:off x="3419856" y="3017520"/>
-            <a:ext cx="5486" cy="1744675"/>
+            <a:ext cx="5486" cy="1664208"/>
           </a:xfrm>
           <a:prstGeom prst="rect">
             <a:avLst/>
@@ -40041,7 +40041,7 @@
         <p:spPr>
           <a:xfrm>
             <a:off x="3895344" y="3017520"/>
-            <a:ext cx="5486" cy="1744675"/>
+            <a:ext cx="5486" cy="1664208"/>
           </a:xfrm>
           <a:prstGeom prst="rect">
             <a:avLst/>
@@ -40100,7 +40100,7 @@
         <p:spPr>
           <a:xfrm>
             <a:off x="4370832" y="3017520"/>
-            <a:ext cx="5486" cy="1744675"/>
+            <a:ext cx="5486" cy="1664208"/>
           </a:xfrm>
           <a:prstGeom prst="rect">
             <a:avLst/>
@@ -40159,7 +40159,7 @@
         <p:spPr>
           <a:xfrm>
             <a:off x="4846320" y="3017520"/>
-            <a:ext cx="5486" cy="1744675"/>
+            <a:ext cx="5486" cy="1664208"/>
           </a:xfrm>
           <a:prstGeom prst="rect">
             <a:avLst/>
@@ -40179,7 +40179,7 @@
         <p:spPr>
           <a:xfrm>
             <a:off x="640080" y="3054096"/>
-            <a:ext cx="1783080" cy="193853"/>
+            <a:ext cx="1783080" cy="237744"/>
           </a:xfrm>
           <a:prstGeom prst="rect">
             <a:avLst/>
@@ -40217,7 +40217,7 @@
         </p:nvSpPr>
         <p:spPr>
           <a:xfrm>
-            <a:off x="2468880" y="3121304"/>
+            <a:off x="2468880" y="3143250"/>
             <a:ext cx="2377440" cy="59436"/>
           </a:xfrm>
           <a:prstGeom prst="roundRect">
@@ -40239,7 +40239,7 @@
         </p:nvSpPr>
         <p:spPr>
           <a:xfrm>
-            <a:off x="2468880" y="3121304"/>
+            <a:off x="2468880" y="3143250"/>
             <a:ext cx="2377440" cy="59436"/>
           </a:xfrm>
           <a:prstGeom prst="roundRect">
@@ -40262,7 +40262,7 @@
         <p:spPr>
           <a:xfrm>
             <a:off x="5029200" y="3054096"/>
-            <a:ext cx="822960" cy="193853"/>
+            <a:ext cx="822960" cy="237744"/>
           </a:xfrm>
           <a:prstGeom prst="rect">
             <a:avLst/>
@@ -40301,7 +40301,7 @@
         <p:spPr>
           <a:xfrm>
             <a:off x="5943600" y="3054096"/>
-            <a:ext cx="822960" cy="193853"/>
+            <a:ext cx="822960" cy="237744"/>
           </a:xfrm>
           <a:prstGeom prst="rect">
             <a:avLst/>
@@ -40339,8 +40339,8 @@
         </p:nvSpPr>
         <p:spPr>
           <a:xfrm>
-            <a:off x="640080" y="3247949"/>
-            <a:ext cx="1783080" cy="193853"/>
+            <a:off x="640080" y="3291840"/>
+            <a:ext cx="1783080" cy="237744"/>
           </a:xfrm>
           <a:prstGeom prst="rect">
             <a:avLst/>
@@ -40378,7 +40378,7 @@
         </p:nvSpPr>
         <p:spPr>
           <a:xfrm>
-            <a:off x="2468880" y="3315157"/>
+            <a:off x="2468880" y="3380994"/>
             <a:ext cx="2377440" cy="59436"/>
           </a:xfrm>
           <a:prstGeom prst="roundRect">
@@ -40400,7 +40400,7 @@
         </p:nvSpPr>
         <p:spPr>
           <a:xfrm>
-            <a:off x="2468880" y="3315157"/>
+            <a:off x="2468880" y="3380994"/>
             <a:ext cx="2370308" cy="59436"/>
           </a:xfrm>
           <a:prstGeom prst="roundRect">
@@ -40422,8 +40422,8 @@
         </p:nvSpPr>
         <p:spPr>
           <a:xfrm>
-            <a:off x="5029200" y="3247949"/>
-            <a:ext cx="822960" cy="193853"/>
+            <a:off x="5029200" y="3291840"/>
+            <a:ext cx="822960" cy="237744"/>
           </a:xfrm>
           <a:prstGeom prst="rect">
             <a:avLst/>
@@ -40461,8 +40461,8 @@
         </p:nvSpPr>
         <p:spPr>
           <a:xfrm>
-            <a:off x="5943600" y="3247949"/>
-            <a:ext cx="822960" cy="193853"/>
+            <a:off x="5943600" y="3291840"/>
+            <a:ext cx="822960" cy="237744"/>
           </a:xfrm>
           <a:prstGeom prst="rect">
             <a:avLst/>
@@ -40500,8 +40500,8 @@
         </p:nvSpPr>
         <p:spPr>
           <a:xfrm>
-            <a:off x="640080" y="3441802"/>
-            <a:ext cx="1783080" cy="193853"/>
+            <a:off x="640080" y="3529584"/>
+            <a:ext cx="1783080" cy="237744"/>
           </a:xfrm>
           <a:prstGeom prst="rect">
             <a:avLst/>
@@ -40525,7 +40525,7 @@
                 <a:ea typeface="Poppins" pitchFamily="34" charset="-122"/>
                 <a:cs typeface="Poppins" pitchFamily="34" charset="-120"/>
               </a:rPr>
-              <a:t>Rhys Woolcock</a:t>
+              <a:t>Isaac Mercado</a:t>
             </a:r>
             <a:endParaRPr lang="en-US" sz="800" dirty="0"/>
           </a:p>
@@ -40539,7 +40539,7 @@
         </p:nvSpPr>
         <p:spPr>
           <a:xfrm>
-            <a:off x="2468880" y="3509010"/>
+            <a:off x="2468880" y="3618738"/>
             <a:ext cx="2377440" cy="59436"/>
           </a:xfrm>
           <a:prstGeom prst="roundRect">
@@ -40561,8 +40561,8 @@
         </p:nvSpPr>
         <p:spPr>
           <a:xfrm>
-            <a:off x="5029200" y="3441802"/>
-            <a:ext cx="822960" cy="193853"/>
+            <a:off x="5029200" y="3529584"/>
+            <a:ext cx="822960" cy="237744"/>
           </a:xfrm>
           <a:prstGeom prst="rect">
             <a:avLst/>
@@ -40600,8 +40600,8 @@
         </p:nvSpPr>
         <p:spPr>
           <a:xfrm>
-            <a:off x="5943600" y="3441802"/>
-            <a:ext cx="822960" cy="193853"/>
+            <a:off x="5943600" y="3529584"/>
+            <a:ext cx="822960" cy="237744"/>
           </a:xfrm>
           <a:prstGeom prst="rect">
             <a:avLst/>
@@ -40639,8 +40639,8 @@
         </p:nvSpPr>
         <p:spPr>
           <a:xfrm>
-            <a:off x="640080" y="3635654"/>
-            <a:ext cx="1783080" cy="193853"/>
+            <a:off x="640080" y="3767328"/>
+            <a:ext cx="1783080" cy="237744"/>
           </a:xfrm>
           <a:prstGeom prst="rect">
             <a:avLst/>
@@ -40664,7 +40664,7 @@
                 <a:ea typeface="Poppins" pitchFamily="34" charset="-122"/>
                 <a:cs typeface="Poppins" pitchFamily="34" charset="-120"/>
               </a:rPr>
-              <a:t>Isaac Mercado</a:t>
+              <a:t>Karim AlRifaii</a:t>
             </a:r>
             <a:endParaRPr lang="en-US" sz="800" dirty="0"/>
           </a:p>
@@ -40678,7 +40678,7 @@
         </p:nvSpPr>
         <p:spPr>
           <a:xfrm>
-            <a:off x="2468880" y="3702863"/>
+            <a:off x="2468880" y="3856482"/>
             <a:ext cx="2377440" cy="59436"/>
           </a:xfrm>
           <a:prstGeom prst="roundRect">
@@ -40700,8 +40700,8 @@
         </p:nvSpPr>
         <p:spPr>
           <a:xfrm>
-            <a:off x="5029200" y="3635654"/>
-            <a:ext cx="822960" cy="193853"/>
+            <a:off x="5029200" y="3767328"/>
+            <a:ext cx="822960" cy="237744"/>
           </a:xfrm>
           <a:prstGeom prst="rect">
             <a:avLst/>
@@ -40739,8 +40739,8 @@
         </p:nvSpPr>
         <p:spPr>
           <a:xfrm>
-            <a:off x="5943600" y="3635654"/>
-            <a:ext cx="822960" cy="193853"/>
+            <a:off x="5943600" y="3767328"/>
+            <a:ext cx="822960" cy="237744"/>
           </a:xfrm>
           <a:prstGeom prst="rect">
             <a:avLst/>
@@ -40778,8 +40778,8 @@
         </p:nvSpPr>
         <p:spPr>
           <a:xfrm>
-            <a:off x="640080" y="3829507"/>
-            <a:ext cx="1783080" cy="193853"/>
+            <a:off x="640080" y="4005072"/>
+            <a:ext cx="1783080" cy="237744"/>
           </a:xfrm>
           <a:prstGeom prst="rect">
             <a:avLst/>
@@ -40803,7 +40803,7 @@
                 <a:ea typeface="Poppins" pitchFamily="34" charset="-122"/>
                 <a:cs typeface="Poppins" pitchFamily="34" charset="-120"/>
               </a:rPr>
-              <a:t>Rodney Nolan</a:t>
+              <a:t>Ryan Neil Orande</a:t>
             </a:r>
             <a:endParaRPr lang="en-US" sz="800" dirty="0"/>
           </a:p>
@@ -40817,7 +40817,7 @@
         </p:nvSpPr>
         <p:spPr>
           <a:xfrm>
-            <a:off x="2468880" y="3896716"/>
+            <a:off x="2468880" y="4094226"/>
             <a:ext cx="2377440" cy="59436"/>
           </a:xfrm>
           <a:prstGeom prst="roundRect">
@@ -40839,8 +40839,8 @@
         </p:nvSpPr>
         <p:spPr>
           <a:xfrm>
-            <a:off x="5029200" y="3829507"/>
-            <a:ext cx="822960" cy="193853"/>
+            <a:off x="5029200" y="4005072"/>
+            <a:ext cx="822960" cy="237744"/>
           </a:xfrm>
           <a:prstGeom prst="rect">
             <a:avLst/>
@@ -40878,8 +40878,8 @@
         </p:nvSpPr>
         <p:spPr>
           <a:xfrm>
-            <a:off x="5943600" y="3829507"/>
-            <a:ext cx="822960" cy="193853"/>
+            <a:off x="5943600" y="4005072"/>
+            <a:ext cx="822960" cy="237744"/>
           </a:xfrm>
           <a:prstGeom prst="rect">
             <a:avLst/>
@@ -40917,8 +40917,8 @@
         </p:nvSpPr>
         <p:spPr>
           <a:xfrm>
-            <a:off x="640080" y="4023360"/>
-            <a:ext cx="1783080" cy="193853"/>
+            <a:off x="640080" y="4242816"/>
+            <a:ext cx="1783080" cy="237744"/>
           </a:xfrm>
           <a:prstGeom prst="rect">
             <a:avLst/>
@@ -40942,7 +40942,7 @@
                 <a:ea typeface="Poppins" pitchFamily="34" charset="-122"/>
                 <a:cs typeface="Poppins" pitchFamily="34" charset="-120"/>
               </a:rPr>
-              <a:t>Karim AlRifaii</a:t>
+              <a:t>Isayah Kuhlmann</a:t>
             </a:r>
             <a:endParaRPr lang="en-US" sz="800" dirty="0"/>
           </a:p>
@@ -40956,7 +40956,7 @@
         </p:nvSpPr>
         <p:spPr>
           <a:xfrm>
-            <a:off x="2468880" y="4090568"/>
+            <a:off x="2468880" y="4331970"/>
             <a:ext cx="2377440" cy="59436"/>
           </a:xfrm>
           <a:prstGeom prst="roundRect">
@@ -40978,8 +40978,8 @@
         </p:nvSpPr>
         <p:spPr>
           <a:xfrm>
-            <a:off x="5029200" y="4023360"/>
-            <a:ext cx="822960" cy="193853"/>
+            <a:off x="5029200" y="4242816"/>
+            <a:ext cx="822960" cy="237744"/>
           </a:xfrm>
           <a:prstGeom prst="rect">
             <a:avLst/>
@@ -41017,8 +41017,8 @@
         </p:nvSpPr>
         <p:spPr>
           <a:xfrm>
-            <a:off x="5943600" y="4023360"/>
-            <a:ext cx="822960" cy="193853"/>
+            <a:off x="5943600" y="4242816"/>
+            <a:ext cx="822960" cy="237744"/>
           </a:xfrm>
           <a:prstGeom prst="rect">
             <a:avLst/>
@@ -41056,8 +41056,8 @@
         </p:nvSpPr>
         <p:spPr>
           <a:xfrm>
-            <a:off x="640080" y="4217213"/>
-            <a:ext cx="1783080" cy="193853"/>
+            <a:off x="640080" y="4480560"/>
+            <a:ext cx="1783080" cy="237744"/>
           </a:xfrm>
           <a:prstGeom prst="rect">
             <a:avLst/>
@@ -41081,7 +41081,7 @@
                 <a:ea typeface="Poppins" pitchFamily="34" charset="-122"/>
                 <a:cs typeface="Poppins" pitchFamily="34" charset="-120"/>
               </a:rPr>
-              <a:t>Ryan Neil Orande</a:t>
+              <a:t>Argenis Rafael Guevara</a:t>
             </a:r>
             <a:endParaRPr lang="en-US" sz="800" dirty="0"/>
           </a:p>
@@ -41095,7 +41095,7 @@
         </p:nvSpPr>
         <p:spPr>
           <a:xfrm>
-            <a:off x="2468880" y="4284421"/>
+            <a:off x="2468880" y="4569714"/>
             <a:ext cx="2377440" cy="59436"/>
           </a:xfrm>
           <a:prstGeom prst="roundRect">
@@ -41117,8 +41117,8 @@
         </p:nvSpPr>
         <p:spPr>
           <a:xfrm>
-            <a:off x="5029200" y="4217213"/>
-            <a:ext cx="822960" cy="193853"/>
+            <a:off x="5029200" y="4480560"/>
+            <a:ext cx="822960" cy="237744"/>
           </a:xfrm>
           <a:prstGeom prst="rect">
             <a:avLst/>
@@ -41156,8 +41156,8 @@
         </p:nvSpPr>
         <p:spPr>
           <a:xfrm>
-            <a:off x="5943600" y="4217213"/>
-            <a:ext cx="822960" cy="193853"/>
+            <a:off x="5943600" y="4480560"/>
+            <a:ext cx="822960" cy="237744"/>
           </a:xfrm>
           <a:prstGeom prst="rect">
             <a:avLst/>
@@ -41189,14 +41189,34 @@
       </p:sp>
       <p:sp>
         <p:nvSpPr>
-          <p:cNvPr id="73" name="Text 71"/>
-          <p:cNvSpPr txBox="1"/>
-          <p:nvPr/>
-        </p:nvSpPr>
-        <p:spPr>
-          <a:xfrm>
-            <a:off x="640080" y="4411066"/>
-            <a:ext cx="1783080" cy="193853"/>
+          <p:cNvPr id="73" name="Shape 71"/>
+          <p:cNvSpPr/>
+          <p:nvPr/>
+        </p:nvSpPr>
+        <p:spPr>
+          <a:xfrm>
+            <a:off x="640080" y="4736592"/>
+            <a:ext cx="6126480" cy="10973"/>
+          </a:xfrm>
+          <a:prstGeom prst="rect">
+            <a:avLst/>
+          </a:prstGeom>
+          <a:solidFill>
+            <a:srgbClr val="12293A"/>
+          </a:solidFill>
+          <a:ln/>
+        </p:spPr>
+      </p:sp>
+      <p:sp>
+        <p:nvSpPr>
+          <p:cNvPr id="74" name="Text 72"/>
+          <p:cNvSpPr txBox="1"/>
+          <p:nvPr/>
+        </p:nvSpPr>
+        <p:spPr>
+          <a:xfrm>
+            <a:off x="640080" y="4764024"/>
+            <a:ext cx="1783080" cy="237744"/>
           </a:xfrm>
           <a:prstGeom prst="rect">
             <a:avLst/>
@@ -41212,7 +41232,46 @@
               <a:buNone/>
             </a:pPr>
             <a:r>
-              <a:rPr lang="en-US" sz="800" dirty="0">
+              <a:rPr lang="en-US" sz="850" b="1" dirty="0">
+                <a:solidFill>
+                  <a:srgbClr val="12293A"/>
+                </a:solidFill>
+                <a:latin typeface="Poppins" pitchFamily="34" charset="0"/>
+                <a:ea typeface="Poppins" pitchFamily="34" charset="-122"/>
+                <a:cs typeface="Poppins" pitchFamily="34" charset="-120"/>
+              </a:rPr>
+              <a:t>TOTAL</a:t>
+            </a:r>
+            <a:endParaRPr lang="en-US" sz="850" dirty="0"/>
+          </a:p>
+        </p:txBody>
+      </p:sp>
+      <p:sp>
+        <p:nvSpPr>
+          <p:cNvPr id="75" name="Text 73"/>
+          <p:cNvSpPr txBox="1"/>
+          <p:nvPr/>
+        </p:nvSpPr>
+        <p:spPr>
+          <a:xfrm>
+            <a:off x="2468880" y="4764024"/>
+            <a:ext cx="2377440" cy="237744"/>
+          </a:xfrm>
+          <a:prstGeom prst="rect">
+            <a:avLst/>
+          </a:prstGeom>
+          <a:noFill/>
+          <a:ln/>
+        </p:spPr>
+        <p:txBody>
+          <a:bodyPr wrap="square" lIns="0" tIns="0" rIns="0" bIns="0" rtlCol="0" anchor="ctr"/>
+          <a:lstStyle/>
+          <a:p>
+            <a:pPr indent="0" marL="0">
+              <a:buNone/>
+            </a:pPr>
+            <a:r>
+              <a:rPr lang="en-US" sz="700" dirty="0">
                 <a:solidFill>
                   <a:srgbClr val="5E7280"/>
                 </a:solidFill>
@@ -41220,44 +41279,22 @@
                 <a:ea typeface="Poppins" pitchFamily="34" charset="-122"/>
                 <a:cs typeface="Poppins" pitchFamily="34" charset="-120"/>
               </a:rPr>
-              <a:t>Isayah Kuhlmann</a:t>
-            </a:r>
-            <a:endParaRPr lang="en-US" sz="800" dirty="0"/>
-          </a:p>
-        </p:txBody>
-      </p:sp>
-      <p:sp>
-        <p:nvSpPr>
-          <p:cNvPr id="74" name="Shape 72"/>
-          <p:cNvSpPr/>
-          <p:nvPr/>
-        </p:nvSpPr>
-        <p:spPr>
-          <a:xfrm>
-            <a:off x="2468880" y="4478274"/>
-            <a:ext cx="2377440" cy="59436"/>
-          </a:xfrm>
-          <a:prstGeom prst="roundRect">
-            <a:avLst>
-              <a:gd name="adj" fmla="val 49231"/>
-            </a:avLst>
-          </a:prstGeom>
-          <a:solidFill>
-            <a:srgbClr val="E2EAEE"/>
-          </a:solidFill>
-          <a:ln/>
-        </p:spPr>
-      </p:sp>
-      <p:sp>
-        <p:nvSpPr>
-          <p:cNvPr id="75" name="Text 73"/>
-          <p:cNvSpPr txBox="1"/>
-          <p:nvPr/>
-        </p:nvSpPr>
-        <p:spPr>
-          <a:xfrm>
-            <a:off x="5029200" y="4411066"/>
-            <a:ext cx="822960" cy="193853"/>
+              <a:t>7 PS people × 38h = 266h available</a:t>
+            </a:r>
+            <a:endParaRPr lang="en-US" sz="700" dirty="0"/>
+          </a:p>
+        </p:txBody>
+      </p:sp>
+      <p:sp>
+        <p:nvSpPr>
+          <p:cNvPr id="76" name="Text 74"/>
+          <p:cNvSpPr txBox="1"/>
+          <p:nvPr/>
+        </p:nvSpPr>
+        <p:spPr>
+          <a:xfrm>
+            <a:off x="5029200" y="4764024"/>
+            <a:ext cx="822960" cy="237744"/>
           </a:xfrm>
           <a:prstGeom prst="rect">
             <a:avLst/>
@@ -41273,30 +41310,30 @@
               <a:buNone/>
             </a:pPr>
             <a:r>
-              <a:rPr lang="en-US" sz="800" dirty="0">
-                <a:solidFill>
-                  <a:srgbClr val="8FA1AC"/>
-                </a:solidFill>
-                <a:latin typeface="Poppins" pitchFamily="34" charset="0"/>
-                <a:ea typeface="Poppins" pitchFamily="34" charset="-122"/>
-                <a:cs typeface="Poppins" pitchFamily="34" charset="-120"/>
-              </a:rPr>
-              <a:t>—</a:t>
-            </a:r>
-            <a:endParaRPr lang="en-US" sz="800" dirty="0"/>
-          </a:p>
-        </p:txBody>
-      </p:sp>
-      <p:sp>
-        <p:nvSpPr>
-          <p:cNvPr id="76" name="Text 74"/>
-          <p:cNvSpPr txBox="1"/>
-          <p:nvPr/>
-        </p:nvSpPr>
-        <p:spPr>
-          <a:xfrm>
-            <a:off x="5943600" y="4411066"/>
-            <a:ext cx="822960" cy="193853"/>
+              <a:rPr lang="en-US" sz="950" b="1" dirty="0">
+                <a:solidFill>
+                  <a:srgbClr val="2C8394"/>
+                </a:solidFill>
+                <a:latin typeface="Poppins" pitchFamily="34" charset="0"/>
+                <a:ea typeface="Poppins" pitchFamily="34" charset="-122"/>
+                <a:cs typeface="Poppins" pitchFamily="34" charset="-120"/>
+              </a:rPr>
+              <a:t>88.87h</a:t>
+            </a:r>
+            <a:endParaRPr lang="en-US" sz="950" dirty="0"/>
+          </a:p>
+        </p:txBody>
+      </p:sp>
+      <p:sp>
+        <p:nvSpPr>
+          <p:cNvPr id="77" name="Text 75"/>
+          <p:cNvSpPr txBox="1"/>
+          <p:nvPr/>
+        </p:nvSpPr>
+        <p:spPr>
+          <a:xfrm>
+            <a:off x="5943600" y="4764024"/>
+            <a:ext cx="822960" cy="237744"/>
           </a:xfrm>
           <a:prstGeom prst="rect">
             <a:avLst/>
@@ -41312,291 +41349,15 @@
               <a:buNone/>
             </a:pPr>
             <a:r>
-              <a:rPr lang="en-US" sz="600" dirty="0">
-                <a:solidFill>
-                  <a:srgbClr val="8FA1AC"/>
-                </a:solidFill>
-                <a:latin typeface="Poppins" pitchFamily="34" charset="0"/>
-                <a:ea typeface="Poppins" pitchFamily="34" charset="-122"/>
-                <a:cs typeface="Poppins" pitchFamily="34" charset="-120"/>
-              </a:rPr>
-              <a:t>no time logged</a:t>
-            </a:r>
-            <a:endParaRPr lang="en-US" sz="600" dirty="0"/>
-          </a:p>
-        </p:txBody>
-      </p:sp>
-      <p:sp>
-        <p:nvSpPr>
-          <p:cNvPr id="77" name="Text 75"/>
-          <p:cNvSpPr txBox="1"/>
-          <p:nvPr/>
-        </p:nvSpPr>
-        <p:spPr>
-          <a:xfrm>
-            <a:off x="640080" y="4604918"/>
-            <a:ext cx="1783080" cy="193853"/>
-          </a:xfrm>
-          <a:prstGeom prst="rect">
-            <a:avLst/>
-          </a:prstGeom>
-          <a:noFill/>
-          <a:ln/>
-        </p:spPr>
-        <p:txBody>
-          <a:bodyPr wrap="square" lIns="0" tIns="0" rIns="0" bIns="0" rtlCol="0" anchor="ctr"/>
-          <a:lstStyle/>
-          <a:p>
-            <a:pPr indent="0" marL="0">
-              <a:buNone/>
-            </a:pPr>
-            <a:r>
-              <a:rPr lang="en-US" sz="800" dirty="0">
-                <a:solidFill>
-                  <a:srgbClr val="5E7280"/>
-                </a:solidFill>
-                <a:latin typeface="Poppins" pitchFamily="34" charset="0"/>
-                <a:ea typeface="Poppins" pitchFamily="34" charset="-122"/>
-                <a:cs typeface="Poppins" pitchFamily="34" charset="-120"/>
-              </a:rPr>
-              <a:t>Argenis Rafael Guevara</a:t>
-            </a:r>
-            <a:endParaRPr lang="en-US" sz="800" dirty="0"/>
-          </a:p>
-        </p:txBody>
-      </p:sp>
-      <p:sp>
-        <p:nvSpPr>
-          <p:cNvPr id="78" name="Shape 76"/>
-          <p:cNvSpPr/>
-          <p:nvPr/>
-        </p:nvSpPr>
-        <p:spPr>
-          <a:xfrm>
-            <a:off x="2468880" y="4672127"/>
-            <a:ext cx="2377440" cy="59436"/>
-          </a:xfrm>
-          <a:prstGeom prst="roundRect">
-            <a:avLst>
-              <a:gd name="adj" fmla="val 49231"/>
-            </a:avLst>
-          </a:prstGeom>
-          <a:solidFill>
-            <a:srgbClr val="E2EAEE"/>
-          </a:solidFill>
-          <a:ln/>
-        </p:spPr>
-      </p:sp>
-      <p:sp>
-        <p:nvSpPr>
-          <p:cNvPr id="79" name="Text 77"/>
-          <p:cNvSpPr txBox="1"/>
-          <p:nvPr/>
-        </p:nvSpPr>
-        <p:spPr>
-          <a:xfrm>
-            <a:off x="5029200" y="4604918"/>
-            <a:ext cx="822960" cy="193853"/>
-          </a:xfrm>
-          <a:prstGeom prst="rect">
-            <a:avLst/>
-          </a:prstGeom>
-          <a:noFill/>
-          <a:ln/>
-        </p:spPr>
-        <p:txBody>
-          <a:bodyPr wrap="square" lIns="0" tIns="0" rIns="0" bIns="0" rtlCol="0" anchor="ctr"/>
-          <a:lstStyle/>
-          <a:p>
-            <a:pPr algn="r" indent="0" marL="0">
-              <a:buNone/>
-            </a:pPr>
-            <a:r>
-              <a:rPr lang="en-US" sz="800" dirty="0">
-                <a:solidFill>
-                  <a:srgbClr val="8FA1AC"/>
-                </a:solidFill>
-                <a:latin typeface="Poppins" pitchFamily="34" charset="0"/>
-                <a:ea typeface="Poppins" pitchFamily="34" charset="-122"/>
-                <a:cs typeface="Poppins" pitchFamily="34" charset="-120"/>
-              </a:rPr>
-              <a:t>—</a:t>
-            </a:r>
-            <a:endParaRPr lang="en-US" sz="800" dirty="0"/>
-          </a:p>
-        </p:txBody>
-      </p:sp>
-      <p:sp>
-        <p:nvSpPr>
-          <p:cNvPr id="80" name="Text 78"/>
-          <p:cNvSpPr txBox="1"/>
-          <p:nvPr/>
-        </p:nvSpPr>
-        <p:spPr>
-          <a:xfrm>
-            <a:off x="5943600" y="4604918"/>
-            <a:ext cx="822960" cy="193853"/>
-          </a:xfrm>
-          <a:prstGeom prst="rect">
-            <a:avLst/>
-          </a:prstGeom>
-          <a:noFill/>
-          <a:ln/>
-        </p:spPr>
-        <p:txBody>
-          <a:bodyPr wrap="square" lIns="0" tIns="0" rIns="0" bIns="0" rtlCol="0" anchor="ctr"/>
-          <a:lstStyle/>
-          <a:p>
-            <a:pPr algn="r" indent="0" marL="0">
-              <a:buNone/>
-            </a:pPr>
-            <a:r>
-              <a:rPr lang="en-US" sz="600" dirty="0">
-                <a:solidFill>
-                  <a:srgbClr val="8FA1AC"/>
-                </a:solidFill>
-                <a:latin typeface="Poppins" pitchFamily="34" charset="0"/>
-                <a:ea typeface="Poppins" pitchFamily="34" charset="-122"/>
-                <a:cs typeface="Poppins" pitchFamily="34" charset="-120"/>
-              </a:rPr>
-              <a:t>no time logged</a:t>
-            </a:r>
-            <a:endParaRPr lang="en-US" sz="600" dirty="0"/>
-          </a:p>
-        </p:txBody>
-      </p:sp>
-      <p:sp>
-        <p:nvSpPr>
-          <p:cNvPr id="81" name="Shape 79"/>
-          <p:cNvSpPr/>
-          <p:nvPr/>
-        </p:nvSpPr>
-        <p:spPr>
-          <a:xfrm>
-            <a:off x="640080" y="4817059"/>
-            <a:ext cx="6126480" cy="10973"/>
-          </a:xfrm>
-          <a:prstGeom prst="rect">
-            <a:avLst/>
-          </a:prstGeom>
-          <a:solidFill>
-            <a:srgbClr val="12293A"/>
-          </a:solidFill>
-          <a:ln/>
-        </p:spPr>
-      </p:sp>
-      <p:sp>
-        <p:nvSpPr>
-          <p:cNvPr id="82" name="Text 80"/>
-          <p:cNvSpPr txBox="1"/>
-          <p:nvPr/>
-        </p:nvSpPr>
-        <p:spPr>
-          <a:xfrm>
-            <a:off x="640080" y="4844491"/>
-            <a:ext cx="1783080" cy="193853"/>
-          </a:xfrm>
-          <a:prstGeom prst="rect">
-            <a:avLst/>
-          </a:prstGeom>
-          <a:noFill/>
-          <a:ln/>
-        </p:spPr>
-        <p:txBody>
-          <a:bodyPr wrap="square" lIns="0" tIns="0" rIns="0" bIns="0" rtlCol="0" anchor="ctr"/>
-          <a:lstStyle/>
-          <a:p>
-            <a:pPr indent="0" marL="0">
-              <a:buNone/>
-            </a:pPr>
-            <a:r>
-              <a:rPr lang="en-US" sz="850" b="1" dirty="0">
-                <a:solidFill>
-                  <a:srgbClr val="12293A"/>
-                </a:solidFill>
-                <a:latin typeface="Poppins" pitchFamily="34" charset="0"/>
-                <a:ea typeface="Poppins" pitchFamily="34" charset="-122"/>
-                <a:cs typeface="Poppins" pitchFamily="34" charset="-120"/>
-              </a:rPr>
-              <a:t>TOTAL</a:t>
-            </a:r>
-            <a:endParaRPr lang="en-US" sz="850" dirty="0"/>
-          </a:p>
-        </p:txBody>
-      </p:sp>
-      <p:sp>
-        <p:nvSpPr>
-          <p:cNvPr id="83" name="Text 81"/>
-          <p:cNvSpPr txBox="1"/>
-          <p:nvPr/>
-        </p:nvSpPr>
-        <p:spPr>
-          <a:xfrm>
-            <a:off x="2468880" y="4844491"/>
-            <a:ext cx="2377440" cy="193853"/>
-          </a:xfrm>
-          <a:prstGeom prst="rect">
-            <a:avLst/>
-          </a:prstGeom>
-          <a:noFill/>
-          <a:ln/>
-        </p:spPr>
-        <p:txBody>
-          <a:bodyPr wrap="square" lIns="0" tIns="0" rIns="0" bIns="0" rtlCol="0" anchor="ctr"/>
-          <a:lstStyle/>
-          <a:p>
-            <a:pPr indent="0" marL="0">
-              <a:buNone/>
-            </a:pPr>
-            <a:r>
-              <a:rPr lang="en-US" sz="700" dirty="0">
-                <a:solidFill>
-                  <a:srgbClr val="5E7280"/>
-                </a:solidFill>
-                <a:latin typeface="Poppins" pitchFamily="34" charset="0"/>
-                <a:ea typeface="Poppins" pitchFamily="34" charset="-122"/>
-                <a:cs typeface="Poppins" pitchFamily="34" charset="-120"/>
-              </a:rPr>
-              <a:t>9 PS people × 38h = 342h available</a:t>
-            </a:r>
-            <a:endParaRPr lang="en-US" sz="700" dirty="0"/>
-          </a:p>
-        </p:txBody>
-      </p:sp>
-      <p:sp>
-        <p:nvSpPr>
-          <p:cNvPr id="84" name="Text 82"/>
-          <p:cNvSpPr txBox="1"/>
-          <p:nvPr/>
-        </p:nvSpPr>
-        <p:spPr>
-          <a:xfrm>
-            <a:off x="5029200" y="4844491"/>
-            <a:ext cx="822960" cy="193853"/>
-          </a:xfrm>
-          <a:prstGeom prst="rect">
-            <a:avLst/>
-          </a:prstGeom>
-          <a:noFill/>
-          <a:ln/>
-        </p:spPr>
-        <p:txBody>
-          <a:bodyPr wrap="square" lIns="0" tIns="0" rIns="0" bIns="0" rtlCol="0" anchor="ctr"/>
-          <a:lstStyle/>
-          <a:p>
-            <a:pPr algn="r" indent="0" marL="0">
-              <a:buNone/>
-            </a:pPr>
-            <a:r>
               <a:rPr lang="en-US" sz="950" b="1" dirty="0">
                 <a:solidFill>
-                  <a:srgbClr val="2C8394"/>
-                </a:solidFill>
-                <a:latin typeface="Poppins" pitchFamily="34" charset="0"/>
-                <a:ea typeface="Poppins" pitchFamily="34" charset="-122"/>
-                <a:cs typeface="Poppins" pitchFamily="34" charset="-120"/>
-              </a:rPr>
-              <a:t>88.87h</a:t>
+                  <a:srgbClr val="C88A2E"/>
+                </a:solidFill>
+                <a:latin typeface="Poppins" pitchFamily="34" charset="0"/>
+                <a:ea typeface="Poppins" pitchFamily="34" charset="-122"/>
+                <a:cs typeface="Poppins" pitchFamily="34" charset="-120"/>
+              </a:rPr>
+              <a:t>33.4%</a:t>
             </a:r>
             <a:endParaRPr lang="en-US" sz="950" dirty="0"/>
           </a:p>
@@ -41604,46 +41365,7 @@
       </p:sp>
       <p:sp>
         <p:nvSpPr>
-          <p:cNvPr id="85" name="Text 83"/>
-          <p:cNvSpPr txBox="1"/>
-          <p:nvPr/>
-        </p:nvSpPr>
-        <p:spPr>
-          <a:xfrm>
-            <a:off x="5943600" y="4844491"/>
-            <a:ext cx="822960" cy="193853"/>
-          </a:xfrm>
-          <a:prstGeom prst="rect">
-            <a:avLst/>
-          </a:prstGeom>
-          <a:noFill/>
-          <a:ln/>
-        </p:spPr>
-        <p:txBody>
-          <a:bodyPr wrap="square" lIns="0" tIns="0" rIns="0" bIns="0" rtlCol="0" anchor="ctr"/>
-          <a:lstStyle/>
-          <a:p>
-            <a:pPr algn="r" indent="0" marL="0">
-              <a:buNone/>
-            </a:pPr>
-            <a:r>
-              <a:rPr lang="en-US" sz="950" b="1" dirty="0">
-                <a:solidFill>
-                  <a:srgbClr val="C88A2E"/>
-                </a:solidFill>
-                <a:latin typeface="Poppins" pitchFamily="34" charset="0"/>
-                <a:ea typeface="Poppins" pitchFamily="34" charset="-122"/>
-                <a:cs typeface="Poppins" pitchFamily="34" charset="-120"/>
-              </a:rPr>
-              <a:t>26.0%</a:t>
-            </a:r>
-            <a:endParaRPr lang="en-US" sz="950" dirty="0"/>
-          </a:p>
-        </p:txBody>
-      </p:sp>
-      <p:sp>
-        <p:nvSpPr>
-          <p:cNvPr id="86" name="Text 84"/>
+          <p:cNvPr id="78" name="Text 76"/>
           <p:cNvSpPr txBox="1"/>
           <p:nvPr/>
         </p:nvSpPr>
@@ -41674,7 +41396,7 @@
                 <a:ea typeface="Poppins" pitchFamily="34" charset="-122"/>
                 <a:cs typeface="Poppins" pitchFamily="34" charset="-120"/>
               </a:rPr>
-              <a:t>Available staff = the 9 PS people on PS-pipeline tickets open now or closed this week, at 38h each. Lopez, Hikuroa, Magabo, Ho, Fenwick and Hettiarachchy hold PS tickets but are not PS staff — they and their hours are excluded.</a:t>
+              <a:t>Available staff = the 7 Professional Services people on PS-pipeline tickets open now or closed this week and not on leave, at 38h each. Rhys Woolcock and Rodney Nolan were on leave and are out of the base. Lopez, Hikuroa, Magabo, Ho, Fenwick and Hettiarachchy hold PS tickets but are not PS staff — they and their hours are excluded.</a:t>
             </a:r>
             <a:endParaRPr lang="en-US" sz="580" dirty="0"/>
           </a:p>
@@ -41682,7 +41404,7 @@
       </p:sp>
       <p:sp>
         <p:nvSpPr>
-          <p:cNvPr id="87" name="Shape 85"/>
+          <p:cNvPr id="79" name="Shape 77"/>
           <p:cNvSpPr/>
           <p:nvPr/>
         </p:nvSpPr>
@@ -41711,7 +41433,7 @@
       </p:sp>
       <p:sp>
         <p:nvSpPr>
-          <p:cNvPr id="88" name="Text 86"/>
+          <p:cNvPr id="80" name="Text 78"/>
           <p:cNvSpPr txBox="1"/>
           <p:nvPr/>
         </p:nvSpPr>
@@ -41764,7 +41486,7 @@
       </p:sp>
       <p:sp>
         <p:nvSpPr>
-          <p:cNvPr id="89" name="Text 87"/>
+          <p:cNvPr id="81" name="Text 79"/>
           <p:cNvSpPr txBox="1"/>
           <p:nvPr/>
         </p:nvSpPr>
@@ -41803,7 +41525,7 @@
       </p:sp>
       <p:sp>
         <p:nvSpPr>
-          <p:cNvPr id="90" name="Text 88"/>
+          <p:cNvPr id="82" name="Text 80"/>
           <p:cNvSpPr txBox="1"/>
           <p:nvPr/>
         </p:nvSpPr>
@@ -41842,7 +41564,7 @@
       </p:sp>
       <p:sp>
         <p:nvSpPr>
-          <p:cNvPr id="91" name="Text 89"/>
+          <p:cNvPr id="83" name="Text 81"/>
           <p:cNvSpPr txBox="1"/>
           <p:nvPr/>
         </p:nvSpPr>
@@ -41881,7 +41603,7 @@
       </p:sp>
       <p:sp>
         <p:nvSpPr>
-          <p:cNvPr id="92" name="Text 90"/>
+          <p:cNvPr id="84" name="Text 82"/>
           <p:cNvSpPr txBox="1"/>
           <p:nvPr/>
         </p:nvSpPr>
@@ -41920,7 +41642,7 @@
       </p:sp>
       <p:sp>
         <p:nvSpPr>
-          <p:cNvPr id="93" name="Shape 91"/>
+          <p:cNvPr id="85" name="Shape 83"/>
           <p:cNvSpPr/>
           <p:nvPr/>
         </p:nvSpPr>
@@ -41942,7 +41664,7 @@
       </p:sp>
       <p:sp>
         <p:nvSpPr>
-          <p:cNvPr id="94" name="Shape 92"/>
+          <p:cNvPr id="86" name="Shape 84"/>
           <p:cNvSpPr/>
           <p:nvPr/>
         </p:nvSpPr>
@@ -41964,7 +41686,7 @@
       </p:sp>
       <p:sp>
         <p:nvSpPr>
-          <p:cNvPr id="95" name="Text 93"/>
+          <p:cNvPr id="87" name="Text 85"/>
           <p:cNvSpPr txBox="1"/>
           <p:nvPr/>
         </p:nvSpPr>
@@ -42003,7 +41725,7 @@
       </p:sp>
       <p:sp>
         <p:nvSpPr>
-          <p:cNvPr id="96" name="Text 94"/>
+          <p:cNvPr id="88" name="Text 86"/>
           <p:cNvSpPr txBox="1"/>
           <p:nvPr/>
         </p:nvSpPr>
@@ -42042,7 +41764,7 @@
       </p:sp>
       <p:sp>
         <p:nvSpPr>
-          <p:cNvPr id="97" name="Text 95"/>
+          <p:cNvPr id="89" name="Text 87"/>
           <p:cNvSpPr txBox="1"/>
           <p:nvPr/>
         </p:nvSpPr>
@@ -42081,7 +41803,7 @@
       </p:sp>
       <p:sp>
         <p:nvSpPr>
-          <p:cNvPr id="98" name="Shape 96"/>
+          <p:cNvPr id="90" name="Shape 88"/>
           <p:cNvSpPr/>
           <p:nvPr/>
         </p:nvSpPr>
@@ -42103,7 +41825,7 @@
       </p:sp>
       <p:sp>
         <p:nvSpPr>
-          <p:cNvPr id="99" name="Shape 97"/>
+          <p:cNvPr id="91" name="Shape 89"/>
           <p:cNvSpPr/>
           <p:nvPr/>
         </p:nvSpPr>
@@ -42125,7 +41847,7 @@
       </p:sp>
       <p:sp>
         <p:nvSpPr>
-          <p:cNvPr id="100" name="Text 98"/>
+          <p:cNvPr id="92" name="Text 90"/>
           <p:cNvSpPr txBox="1"/>
           <p:nvPr/>
         </p:nvSpPr>
@@ -42164,7 +41886,7 @@
       </p:sp>
       <p:sp>
         <p:nvSpPr>
-          <p:cNvPr id="101" name="Text 99"/>
+          <p:cNvPr id="93" name="Text 91"/>
           <p:cNvSpPr txBox="1"/>
           <p:nvPr/>
         </p:nvSpPr>
@@ -42203,7 +41925,7 @@
       </p:sp>
       <p:sp>
         <p:nvSpPr>
-          <p:cNvPr id="102" name="Text 100"/>
+          <p:cNvPr id="94" name="Text 92"/>
           <p:cNvSpPr txBox="1"/>
           <p:nvPr/>
         </p:nvSpPr>
@@ -42242,7 +41964,7 @@
       </p:sp>
       <p:sp>
         <p:nvSpPr>
-          <p:cNvPr id="103" name="Shape 101"/>
+          <p:cNvPr id="95" name="Shape 93"/>
           <p:cNvSpPr/>
           <p:nvPr/>
         </p:nvSpPr>
@@ -42264,7 +41986,7 @@
       </p:sp>
       <p:sp>
         <p:nvSpPr>
-          <p:cNvPr id="104" name="Shape 102"/>
+          <p:cNvPr id="96" name="Shape 94"/>
           <p:cNvSpPr/>
           <p:nvPr/>
         </p:nvSpPr>
@@ -42286,7 +42008,7 @@
       </p:sp>
       <p:sp>
         <p:nvSpPr>
-          <p:cNvPr id="105" name="Text 103"/>
+          <p:cNvPr id="97" name="Text 95"/>
           <p:cNvSpPr txBox="1"/>
           <p:nvPr/>
         </p:nvSpPr>
@@ -42325,7 +42047,7 @@
       </p:sp>
       <p:sp>
         <p:nvSpPr>
-          <p:cNvPr id="106" name="Text 104"/>
+          <p:cNvPr id="98" name="Text 96"/>
           <p:cNvSpPr txBox="1"/>
           <p:nvPr/>
         </p:nvSpPr>
@@ -42364,7 +42086,7 @@
       </p:sp>
       <p:sp>
         <p:nvSpPr>
-          <p:cNvPr id="107" name="Text 105"/>
+          <p:cNvPr id="99" name="Text 97"/>
           <p:cNvSpPr txBox="1"/>
           <p:nvPr/>
         </p:nvSpPr>
@@ -42403,7 +42125,7 @@
       </p:sp>
       <p:sp>
         <p:nvSpPr>
-          <p:cNvPr id="108" name="Shape 106"/>
+          <p:cNvPr id="100" name="Shape 98"/>
           <p:cNvSpPr/>
           <p:nvPr/>
         </p:nvSpPr>
@@ -42425,7 +42147,7 @@
       </p:sp>
       <p:sp>
         <p:nvSpPr>
-          <p:cNvPr id="109" name="Shape 107"/>
+          <p:cNvPr id="101" name="Shape 99"/>
           <p:cNvSpPr/>
           <p:nvPr/>
         </p:nvSpPr>
@@ -42447,7 +42169,7 @@
       </p:sp>
       <p:sp>
         <p:nvSpPr>
-          <p:cNvPr id="110" name="Text 108"/>
+          <p:cNvPr id="102" name="Text 100"/>
           <p:cNvSpPr txBox="1"/>
           <p:nvPr/>
         </p:nvSpPr>
@@ -42486,7 +42208,7 @@
       </p:sp>
       <p:sp>
         <p:nvSpPr>
-          <p:cNvPr id="111" name="Text 109"/>
+          <p:cNvPr id="103" name="Text 101"/>
           <p:cNvSpPr txBox="1"/>
           <p:nvPr/>
         </p:nvSpPr>
@@ -42525,7 +42247,7 @@
       </p:sp>
       <p:sp>
         <p:nvSpPr>
-          <p:cNvPr id="112" name="Text 110"/>
+          <p:cNvPr id="104" name="Text 102"/>
           <p:cNvSpPr txBox="1"/>
           <p:nvPr/>
         </p:nvSpPr>
@@ -42564,7 +42286,7 @@
       </p:sp>
       <p:sp>
         <p:nvSpPr>
-          <p:cNvPr id="113" name="Shape 111"/>
+          <p:cNvPr id="105" name="Shape 103"/>
           <p:cNvSpPr/>
           <p:nvPr/>
         </p:nvSpPr>
@@ -42586,7 +42308,7 @@
       </p:sp>
       <p:sp>
         <p:nvSpPr>
-          <p:cNvPr id="114" name="Shape 112"/>
+          <p:cNvPr id="106" name="Shape 104"/>
           <p:cNvSpPr/>
           <p:nvPr/>
         </p:nvSpPr>
@@ -42608,7 +42330,7 @@
       </p:sp>
       <p:sp>
         <p:nvSpPr>
-          <p:cNvPr id="115" name="Text 113"/>
+          <p:cNvPr id="107" name="Text 105"/>
           <p:cNvSpPr txBox="1"/>
           <p:nvPr/>
         </p:nvSpPr>
@@ -42647,7 +42369,7 @@
       </p:sp>
       <p:sp>
         <p:nvSpPr>
-          <p:cNvPr id="116" name="Text 114"/>
+          <p:cNvPr id="108" name="Text 106"/>
           <p:cNvSpPr txBox="1"/>
           <p:nvPr/>
         </p:nvSpPr>
@@ -42686,7 +42408,7 @@
       </p:sp>
       <p:sp>
         <p:nvSpPr>
-          <p:cNvPr id="117" name="Text 115"/>
+          <p:cNvPr id="109" name="Text 107"/>
           <p:cNvSpPr txBox="1"/>
           <p:nvPr/>
         </p:nvSpPr>
@@ -42725,7 +42447,7 @@
       </p:sp>
       <p:sp>
         <p:nvSpPr>
-          <p:cNvPr id="118" name="Shape 116"/>
+          <p:cNvPr id="110" name="Shape 108"/>
           <p:cNvSpPr/>
           <p:nvPr/>
         </p:nvSpPr>
@@ -42747,7 +42469,7 @@
       </p:sp>
       <p:sp>
         <p:nvSpPr>
-          <p:cNvPr id="119" name="Text 117"/>
+          <p:cNvPr id="111" name="Text 109"/>
           <p:cNvSpPr txBox="1"/>
           <p:nvPr/>
         </p:nvSpPr>
@@ -42786,7 +42508,7 @@
       </p:sp>
       <p:sp>
         <p:nvSpPr>
-          <p:cNvPr id="120" name="Text 118"/>
+          <p:cNvPr id="112" name="Text 110"/>
           <p:cNvSpPr txBox="1"/>
           <p:nvPr/>
         </p:nvSpPr>
@@ -42825,7 +42547,7 @@
       </p:sp>
       <p:sp>
         <p:nvSpPr>
-          <p:cNvPr id="121" name="Shape 119"/>
+          <p:cNvPr id="113" name="Shape 111"/>
           <p:cNvSpPr/>
           <p:nvPr/>
         </p:nvSpPr>
@@ -42845,7 +42567,7 @@
       </p:sp>
       <p:sp>
         <p:nvSpPr>
-          <p:cNvPr id="122" name="Text 120"/>
+          <p:cNvPr id="114" name="Text 112"/>
           <p:cNvSpPr txBox="1"/>
           <p:nvPr/>
         </p:nvSpPr>
@@ -42884,7 +42606,7 @@
       </p:sp>
       <p:sp>
         <p:nvSpPr>
-          <p:cNvPr id="123" name="Text 121"/>
+          <p:cNvPr id="115" name="Text 113"/>
           <p:cNvSpPr txBox="1"/>
           <p:nvPr/>
         </p:nvSpPr>
@@ -42923,7 +42645,7 @@
       </p:sp>
       <p:sp>
         <p:nvSpPr>
-          <p:cNvPr id="124" name="Text 122"/>
+          <p:cNvPr id="116" name="Text 114"/>
           <p:cNvSpPr txBox="1"/>
           <p:nvPr/>
         </p:nvSpPr>
@@ -42962,7 +42684,7 @@
       </p:sp>
       <p:sp>
         <p:nvSpPr>
-          <p:cNvPr id="125" name="Text 123"/>
+          <p:cNvPr id="117" name="Text 115"/>
           <p:cNvSpPr txBox="1"/>
           <p:nvPr/>
         </p:nvSpPr>
@@ -43001,7 +42723,7 @@
       </p:sp>
       <p:sp>
         <p:nvSpPr>
-          <p:cNvPr id="126" name="Shape 124"/>
+          <p:cNvPr id="118" name="Shape 116"/>
           <p:cNvSpPr/>
           <p:nvPr/>
         </p:nvSpPr>
@@ -43030,7 +42752,7 @@
       </p:sp>
       <p:sp>
         <p:nvSpPr>
-          <p:cNvPr id="127" name="Text 125"/>
+          <p:cNvPr id="119" name="Text 117"/>
           <p:cNvSpPr txBox="1"/>
           <p:nvPr/>
         </p:nvSpPr>
@@ -43083,7 +42805,7 @@
       </p:sp>
       <p:sp>
         <p:nvSpPr>
-          <p:cNvPr id="128" name="Text 126"/>
+          <p:cNvPr id="120" name="Text 118"/>
           <p:cNvSpPr txBox="1"/>
           <p:nvPr/>
         </p:nvSpPr>
@@ -43122,7 +42844,7 @@
       </p:sp>
       <p:sp>
         <p:nvSpPr>
-          <p:cNvPr id="129" name="Text 127"/>
+          <p:cNvPr id="121" name="Text 119"/>
           <p:cNvSpPr txBox="1"/>
           <p:nvPr/>
         </p:nvSpPr>
@@ -43161,7 +42883,7 @@
       </p:sp>
       <p:sp>
         <p:nvSpPr>
-          <p:cNvPr id="130" name="Text 128"/>
+          <p:cNvPr id="122" name="Text 120"/>
           <p:cNvSpPr txBox="1"/>
           <p:nvPr/>
         </p:nvSpPr>
@@ -43200,7 +42922,7 @@
       </p:sp>
       <p:sp>
         <p:nvSpPr>
-          <p:cNvPr id="131" name="Text 129"/>
+          <p:cNvPr id="123" name="Text 121"/>
           <p:cNvSpPr txBox="1"/>
           <p:nvPr/>
         </p:nvSpPr>
@@ -43239,7 +42961,7 @@
       </p:sp>
       <p:sp>
         <p:nvSpPr>
-          <p:cNvPr id="132" name="Text 130"/>
+          <p:cNvPr id="124" name="Text 122"/>
           <p:cNvSpPr txBox="1"/>
           <p:nvPr/>
         </p:nvSpPr>
@@ -43278,7 +43000,7 @@
       </p:sp>
       <p:sp>
         <p:nvSpPr>
-          <p:cNvPr id="133" name="Shape 131"/>
+          <p:cNvPr id="125" name="Shape 123"/>
           <p:cNvSpPr/>
           <p:nvPr/>
         </p:nvSpPr>
@@ -43298,7 +43020,7 @@
       </p:sp>
       <p:sp>
         <p:nvSpPr>
-          <p:cNvPr id="134" name="Text 132"/>
+          <p:cNvPr id="126" name="Text 124"/>
           <p:cNvSpPr txBox="1"/>
           <p:nvPr/>
         </p:nvSpPr>
@@ -43337,7 +43059,7 @@
       </p:sp>
       <p:sp>
         <p:nvSpPr>
-          <p:cNvPr id="135" name="Text 133"/>
+          <p:cNvPr id="127" name="Text 125"/>
           <p:cNvSpPr txBox="1"/>
           <p:nvPr/>
         </p:nvSpPr>
@@ -43376,7 +43098,7 @@
       </p:sp>
       <p:sp>
         <p:nvSpPr>
-          <p:cNvPr id="136" name="Text 134"/>
+          <p:cNvPr id="128" name="Text 126"/>
           <p:cNvSpPr txBox="1"/>
           <p:nvPr/>
         </p:nvSpPr>
@@ -43415,7 +43137,7 @@
       </p:sp>
       <p:sp>
         <p:nvSpPr>
-          <p:cNvPr id="137" name="Text 135"/>
+          <p:cNvPr id="129" name="Text 127"/>
           <p:cNvSpPr txBox="1"/>
           <p:nvPr/>
         </p:nvSpPr>
@@ -43454,7 +43176,7 @@
       </p:sp>
       <p:sp>
         <p:nvSpPr>
-          <p:cNvPr id="138" name="Text 136"/>
+          <p:cNvPr id="130" name="Text 128"/>
           <p:cNvSpPr txBox="1"/>
           <p:nvPr/>
         </p:nvSpPr>
@@ -43493,7 +43215,7 @@
       </p:sp>
       <p:sp>
         <p:nvSpPr>
-          <p:cNvPr id="139" name="Shape 137"/>
+          <p:cNvPr id="131" name="Shape 129"/>
           <p:cNvSpPr/>
           <p:nvPr/>
         </p:nvSpPr>
@@ -43513,7 +43235,7 @@
       </p:sp>
       <p:sp>
         <p:nvSpPr>
-          <p:cNvPr id="140" name="Text 138"/>
+          <p:cNvPr id="132" name="Text 130"/>
           <p:cNvSpPr txBox="1"/>
           <p:nvPr/>
         </p:nvSpPr>
@@ -43552,7 +43274,7 @@
       </p:sp>
       <p:sp>
         <p:nvSpPr>
-          <p:cNvPr id="141" name="Text 139"/>
+          <p:cNvPr id="133" name="Text 131"/>
           <p:cNvSpPr txBox="1"/>
           <p:nvPr/>
         </p:nvSpPr>
@@ -43591,7 +43313,7 @@
       </p:sp>
       <p:sp>
         <p:nvSpPr>
-          <p:cNvPr id="142" name="Text 140"/>
+          <p:cNvPr id="134" name="Text 132"/>
           <p:cNvSpPr txBox="1"/>
           <p:nvPr/>
         </p:nvSpPr>
@@ -43630,7 +43352,7 @@
       </p:sp>
       <p:sp>
         <p:nvSpPr>
-          <p:cNvPr id="143" name="Text 141"/>
+          <p:cNvPr id="135" name="Text 133"/>
           <p:cNvSpPr txBox="1"/>
           <p:nvPr/>
         </p:nvSpPr>
@@ -43669,7 +43391,7 @@
       </p:sp>
       <p:sp>
         <p:nvSpPr>
-          <p:cNvPr id="144" name="Text 142"/>
+          <p:cNvPr id="136" name="Text 134"/>
           <p:cNvSpPr txBox="1"/>
           <p:nvPr/>
         </p:nvSpPr>
@@ -43708,7 +43430,7 @@
       </p:sp>
       <p:sp>
         <p:nvSpPr>
-          <p:cNvPr id="145" name="Shape 143"/>
+          <p:cNvPr id="137" name="Shape 135"/>
           <p:cNvSpPr/>
           <p:nvPr/>
         </p:nvSpPr>
@@ -43728,7 +43450,7 @@
       </p:sp>
       <p:sp>
         <p:nvSpPr>
-          <p:cNvPr id="146" name="Text 144"/>
+          <p:cNvPr id="138" name="Text 136"/>
           <p:cNvSpPr txBox="1"/>
           <p:nvPr/>
         </p:nvSpPr>
@@ -43767,7 +43489,7 @@
       </p:sp>
       <p:sp>
         <p:nvSpPr>
-          <p:cNvPr id="147" name="Text 145"/>
+          <p:cNvPr id="139" name="Text 137"/>
           <p:cNvSpPr txBox="1"/>
           <p:nvPr/>
         </p:nvSpPr>
@@ -43806,7 +43528,7 @@
       </p:sp>
       <p:sp>
         <p:nvSpPr>
-          <p:cNvPr id="148" name="Text 146"/>
+          <p:cNvPr id="140" name="Text 138"/>
           <p:cNvSpPr txBox="1"/>
           <p:nvPr/>
         </p:nvSpPr>
@@ -43845,7 +43567,7 @@
       </p:sp>
       <p:sp>
         <p:nvSpPr>
-          <p:cNvPr id="149" name="Text 147"/>
+          <p:cNvPr id="141" name="Text 139"/>
           <p:cNvSpPr txBox="1"/>
           <p:nvPr/>
         </p:nvSpPr>
@@ -43884,7 +43606,7 @@
       </p:sp>
       <p:sp>
         <p:nvSpPr>
-          <p:cNvPr id="150" name="Text 148"/>
+          <p:cNvPr id="142" name="Text 140"/>
           <p:cNvSpPr txBox="1"/>
           <p:nvPr/>
         </p:nvSpPr>
@@ -43923,7 +43645,7 @@
       </p:sp>
       <p:sp>
         <p:nvSpPr>
-          <p:cNvPr id="151" name="Shape 149"/>
+          <p:cNvPr id="143" name="Shape 141"/>
           <p:cNvSpPr/>
           <p:nvPr/>
         </p:nvSpPr>
@@ -43943,7 +43665,7 @@
       </p:sp>
       <p:sp>
         <p:nvSpPr>
-          <p:cNvPr id="152" name="Text 150"/>
+          <p:cNvPr id="144" name="Text 142"/>
           <p:cNvSpPr txBox="1"/>
           <p:nvPr/>
         </p:nvSpPr>
@@ -43982,7 +43704,7 @@
       </p:sp>
       <p:sp>
         <p:nvSpPr>
-          <p:cNvPr id="153" name="Text 151"/>
+          <p:cNvPr id="145" name="Text 143"/>
           <p:cNvSpPr txBox="1"/>
           <p:nvPr/>
         </p:nvSpPr>
@@ -44021,7 +43743,7 @@
       </p:sp>
       <p:sp>
         <p:nvSpPr>
-          <p:cNvPr id="154" name="Text 152"/>
+          <p:cNvPr id="146" name="Text 144"/>
           <p:cNvSpPr txBox="1"/>
           <p:nvPr/>
         </p:nvSpPr>
@@ -44060,7 +43782,7 @@
       </p:sp>
       <p:sp>
         <p:nvSpPr>
-          <p:cNvPr id="155" name="Text 153"/>
+          <p:cNvPr id="147" name="Text 145"/>
           <p:cNvSpPr txBox="1"/>
           <p:nvPr/>
         </p:nvSpPr>
@@ -44091,7 +43813,7 @@
                 <a:ea typeface="Poppins" pitchFamily="34" charset="-122"/>
                 <a:cs typeface="Poppins" pitchFamily="34" charset="-120"/>
               </a:rPr>
-              <a:t>26.0%</a:t>
+              <a:t>33.4%</a:t>
             </a:r>
             <a:endParaRPr lang="en-US" sz="750" dirty="0"/>
           </a:p>
@@ -44099,7 +43821,7 @@
       </p:sp>
       <p:sp>
         <p:nvSpPr>
-          <p:cNvPr id="156" name="Text 154"/>
+          <p:cNvPr id="148" name="Text 146"/>
           <p:cNvSpPr txBox="1"/>
           <p:nvPr/>
         </p:nvSpPr>
@@ -44138,7 +43860,7 @@
       </p:sp>
       <p:sp>
         <p:nvSpPr>
-          <p:cNvPr id="157" name="Text 155"/>
+          <p:cNvPr id="149" name="Text 147"/>
           <p:cNvSpPr txBox="1"/>
           <p:nvPr/>
         </p:nvSpPr>
@@ -44169,7 +43891,7 @@
                 <a:ea typeface="Poppins" pitchFamily="34" charset="-122"/>
                 <a:cs typeface="Poppins" pitchFamily="34" charset="-120"/>
               </a:rPr>
-              <a:t>Every closed week has restated upward since first reporting. Base held at 9 PS staff × 38h. A 722h record on 21–27 Sep is excluded as a keying error.</a:t>
+              <a:t>Base is available staff × 38h: 9 for the first three weeks, 7 for 28 Sep–4 Oct with Rhys Woolcock and Rodney Nolan on leave. Every closed week has restated upward since first reporting. A 722h record on 21–27 Sep is excluded as a keying error.</a:t>
             </a:r>
             <a:endParaRPr lang="en-US" sz="580" dirty="0"/>
           </a:p>
@@ -44177,7 +43899,7 @@
       </p:sp>
       <p:sp>
         <p:nvSpPr>
-          <p:cNvPr id="158" name="Shape 156"/>
+          <p:cNvPr id="150" name="Shape 148"/>
           <p:cNvSpPr/>
           <p:nvPr/>
         </p:nvSpPr>
@@ -44206,7 +43928,7 @@
       </p:sp>
       <p:sp>
         <p:nvSpPr>
-          <p:cNvPr id="159" name="Text 157"/>
+          <p:cNvPr id="151" name="Text 149"/>
           <p:cNvSpPr txBox="1"/>
           <p:nvPr/>
         </p:nvSpPr>
@@ -44245,7 +43967,7 @@
       </p:sp>
       <p:sp>
         <p:nvSpPr>
-          <p:cNvPr id="160" name="Text 158"/>
+          <p:cNvPr id="152" name="Text 150"/>
           <p:cNvSpPr txBox="1"/>
           <p:nvPr/>
         </p:nvSpPr>
@@ -44307,7 +44029,7 @@
                 <a:ea typeface="Poppins" pitchFamily="34" charset="-122"/>
                 <a:cs typeface="Poppins" pitchFamily="34" charset="-120"/>
               </a:rPr>
-              <a:t>21–27 Sep went out at 20.75h (6.1%) and now stands at 37.25h (10.9%); the two weeks before it have grown too. This week's 26% is a floor, not a result.</a:t>
+              <a:t>21–27 Sep went out at 20.75h (6.1%) and now stands at 37.25h (10.9%); the two weeks before it have grown too. This week's 33.4% is a floor, not a result.</a:t>
             </a:r>
             <a:endParaRPr lang="en-US" sz="900" dirty="0"/>
           </a:p>
@@ -44355,7 +44077,7 @@
                 <a:ea typeface="Poppins" pitchFamily="34" charset="-122"/>
                 <a:cs typeface="Poppins" pitchFamily="34" charset="-120"/>
               </a:rPr>
-              <a:t>Gregory St Clare-Hobbs 51.00h, of which 50.5h sits on one hardware record; Joshua Casey 37.87h across 21 items; 7 logged nothing. Strip that record and utilisation is 11.2%.</a:t>
+              <a:t>Gregory St Clare-Hobbs 51.00h, of which 50.5h sits on one hardware record; Joshua Casey 37.87h across 21 items; 5 logged nothing. Strip that record and utilisation is 14.4%.</a:t>
             </a:r>
             <a:endParaRPr lang="en-US" sz="900" dirty="0"/>
           </a:p>
@@ -44363,7 +44085,7 @@
       </p:sp>
       <p:sp>
         <p:nvSpPr>
-          <p:cNvPr id="161" name="Shape 159"/>
+          <p:cNvPr id="153" name="Shape 151"/>
           <p:cNvSpPr/>
           <p:nvPr/>
         </p:nvSpPr>
@@ -44385,7 +44107,7 @@
       </p:sp>
       <p:sp>
         <p:nvSpPr>
-          <p:cNvPr id="162" name="Text 160"/>
+          <p:cNvPr id="154" name="Text 152"/>
           <p:cNvSpPr txBox="1"/>
           <p:nvPr/>
         </p:nvSpPr>

</xml_diff>